<commit_message>
Implement AES-GCM secure message flow
</commit_message>
<xml_diff>
--- a/presentation/secure-message-presentation.pptx
+++ b/presentation/secure-message-presentation.pptx
@@ -4701,7 +4701,7 @@
         <p:spPr>
           <a:xfrm>
             <a:off x="713232" y="3090672"/>
-            <a:ext cx="7315200" cy="274320"/>
+            <a:ext cx="8046720" cy="274320"/>
           </a:xfrm>
           <a:prstGeom prst="rect">
             <a:avLst/>
@@ -4722,7 +4722,7 @@
                 </a:solidFill>
                 <a:latin typeface="Malgun Gothic"/>
               </a:rPr>
-              <a:t>허프만 트리 · XOR 부울대수 · 다익스트라 알고리즘</a:t>
+              <a:t>허프만 트리 · AES-GCM · XOR 학습 모드 · 다익스트라 알고리즘</a:t>
             </a:r>
           </a:p>
         </p:txBody>
@@ -5102,7 +5102,7 @@
                 </a:solidFill>
                 <a:latin typeface="Malgun Gothic"/>
               </a:rPr>
-              <a:t>XOR</a:t>
+              <a:t>AES</a:t>
             </a:r>
           </a:p>
         </p:txBody>
@@ -7245,7 +7245,7 @@
                 </a:solidFill>
                 <a:latin typeface="Malgun Gothic"/>
               </a:rPr>
-              <a:t>“이산수학으로 보낸 비밀 메시지”와 키 입력</a:t>
+              <a:t>“이산수학으로 보낸 비밀 메시지”와 비밀번호 입력</a:t>
             </a:r>
           </a:p>
         </p:txBody>
@@ -7430,7 +7430,7 @@
                 </a:solidFill>
                 <a:latin typeface="Malgun Gothic"/>
               </a:rPr>
-              <a:t>트리 생성, 압축 결과, SHA-256 키 표시</a:t>
+              <a:t>트리 생성, PBKDF2 키 유도, AES-GCM 인증 암호화</a:t>
             </a:r>
           </a:p>
         </p:txBody>
@@ -7615,7 +7615,7 @@
                 </a:solidFill>
                 <a:latin typeface="Malgun Gothic"/>
               </a:rPr>
-              <a:t>.enc 파일 생성 또는 Supabase 보관함 업로드</a:t>
+              <a:t>SME2 .enc 파일 생성 또는 Supabase 보관함 업로드</a:t>
             </a:r>
           </a:p>
         </p:txBody>
@@ -7985,7 +7985,7 @@
                 </a:solidFill>
                 <a:latin typeface="Malgun Gothic"/>
               </a:rPr>
-              <a:t>같은 키로 복원, 무결성 검증 통과 확인</a:t>
+              <a:t>같은 키로 복원, 인증 검증 통과 확인</a:t>
             </a:r>
           </a:p>
         </p:txBody>
@@ -9701,7 +9701,7 @@
                 </a:solidFill>
                 <a:latin typeface="Malgun Gothic"/>
               </a:rPr>
-              <a:t>보안상 의미 있는 점과 분명한 한계</a:t>
+              <a:t>보호되는 것과 남아 있는 한계</a:t>
             </a:r>
           </a:p>
         </p:txBody>
@@ -9736,7 +9736,7 @@
                 </a:solidFill>
                 <a:latin typeface="Malgun Gothic"/>
               </a:rPr>
-              <a:t>교육용 구현의 범위를 정확히 밝히는 것이 더 안전한 시스템 설계의 출발점입니다.</a:t>
+              <a:t>검증된 인증 암호를 적용해도 공개 공유 환경의 접근 제어 문제는 별도로 남습니다.</a:t>
             </a:r>
           </a:p>
         </p:txBody>
@@ -10063,7 +10063,7 @@
                 </a:solidFill>
                 <a:latin typeface="Consolas"/>
               </a:rPr>
-              <a:t>EDUCATIONAL LIMIT</a:t>
+              <a:t>DEFAULT SECURITY</a:t>
             </a:r>
           </a:p>
         </p:txBody>
@@ -10098,7 +10098,7 @@
                 </a:solidFill>
                 <a:latin typeface="Malgun Gothic"/>
               </a:rPr>
-              <a:t>학습용 한계</a:t>
+              <a:t>기본 암호화</a:t>
             </a:r>
           </a:p>
         </p:txBody>
@@ -10133,9 +10133,9 @@
                 </a:solidFill>
                 <a:latin typeface="Malgun Gothic"/>
               </a:rPr>
-              <a:t>SHA-256 결과 32바이트를
-반복 XOR하므로 실제 서비스의
-인증 암호를 대체하지 못함</a:t>
+              <a:t>새 salt + PBKDF2 250,000회
+새 IV + AES-256-GCM
+헤더와 암호문의 변조를 검출</a:t>
             </a:r>
           </a:p>
         </p:txBody>
@@ -10262,7 +10262,7 @@
                 </a:solidFill>
                 <a:latin typeface="Consolas"/>
               </a:rPr>
-              <a:t>NEXT STEP</a:t>
+              <a:t>REMAINING LIMITS</a:t>
             </a:r>
           </a:p>
         </p:txBody>
@@ -10297,7 +10297,7 @@
                 </a:solidFill>
                 <a:latin typeface="Malgun Gothic"/>
               </a:rPr>
-              <a:t>실서비스 개선</a:t>
+              <a:t>공유 환경의 한계</a:t>
             </a:r>
           </a:p>
         </p:txBody>
@@ -10332,9 +10332,9 @@
                 </a:solidFill>
                 <a:latin typeface="Malgun Gothic"/>
               </a:rPr>
-              <a:t>nonce/IV + AES-GCM
-인증·권한 관리·업로드 제한
-자동 삭제·감사 로그</a:t>
+              <a:t>공개 보관함 정책에서는
+접근 제어가 부족할 수 있음
+권한 관리·삭제·감사 로그 필요</a:t>
             </a:r>
           </a:p>
         </p:txBody>
@@ -12132,7 +12132,7 @@
                 </a:solidFill>
                 <a:latin typeface="Consolas"/>
               </a:rPr>
-              <a:t>XOR</a:t>
+              <a:t>AES-GCM</a:t>
             </a:r>
           </a:p>
         </p:txBody>
@@ -12252,7 +12252,7 @@
         <p:spPr>
           <a:xfrm>
             <a:off x="731520" y="3520440"/>
-            <a:ext cx="9784080" cy="320040"/>
+            <a:ext cx="10424160" cy="320040"/>
           </a:xfrm>
           <a:prstGeom prst="rect">
             <a:avLst/>
@@ -12267,13 +12267,13 @@
           <a:p>
             <a:pPr algn="l"/>
             <a:r>
-              <a:rPr sz="1500" b="0">
+              <a:rPr sz="1400" b="0">
                 <a:solidFill>
                   <a:srgbClr val="A6C3C7"/>
                 </a:solidFill>
                 <a:latin typeface="Malgun Gothic"/>
               </a:rPr>
-              <a:t>허프만 트리는 효율을, XOR은 기밀성의 원리를, 다익스트라는 전달의 최적화를 설명합니다.</a:t>
+              <a:t>허프만 트리는 효율을, AES-GCM은 기밀성·무결성을, XOR은 부울대수 원리를, 다익스트라는 전달의 최적화를 설명합니다.</a:t>
             </a:r>
           </a:p>
         </p:txBody>
@@ -14597,7 +14597,7 @@
                 </a:solidFill>
                 <a:latin typeface="Malgun Gothic"/>
               </a:rPr>
-              <a:t>허프만 / XOR / 다익스트라</a:t>
+              <a:t>허프만 / AES-GCM / XOR 학습 / 다익스트라</a:t>
             </a:r>
           </a:p>
         </p:txBody>
@@ -14901,7 +14901,7 @@
                 </a:solidFill>
                 <a:latin typeface="Malgun Gothic"/>
               </a:rPr>
-              <a:t>교육용 암호의 한계 및 개선 방향</a:t>
+              <a:t>공개 보관함의 한계 및 개선 방향</a:t>
             </a:r>
           </a:p>
         </p:txBody>
@@ -16977,7 +16977,7 @@
                 </a:solidFill>
                 <a:latin typeface="Malgun Gothic"/>
               </a:rPr>
-              <a:t>기밀성</a:t>
+              <a:t>기밀성·무결성</a:t>
             </a:r>
           </a:p>
         </p:txBody>
@@ -17012,8 +17012,8 @@
                 </a:solidFill>
                 <a:latin typeface="Malgun Gothic"/>
               </a:rPr>
-              <a:t>전송 중 내용을 읽을 수 없어야 한다.
-→ 키와 XOR 연산</a:t>
+              <a:t>전송 중 내용을 읽거나 바꾸지 못해야 한다.
+→ PBKDF2 + AES-GCM</a:t>
             </a:r>
           </a:p>
         </p:txBody>
@@ -19635,7 +19635,7 @@
                 </a:solidFill>
                 <a:latin typeface="Malgun Gothic"/>
               </a:rPr>
-              <a:t>XOR 암호화</a:t>
+              <a:t>키 유도·암호화</a:t>
             </a:r>
           </a:p>
         </p:txBody>
@@ -19670,7 +19670,7 @@
                 </a:solidFill>
                 <a:latin typeface="Malgun Gothic"/>
               </a:rPr>
-              <a:t>SHA-256 키 재료</a:t>
+              <a:t>PBKDF2 + AES-GCM</a:t>
             </a:r>
           </a:p>
         </p:txBody>
@@ -19902,7 +19902,7 @@
                 </a:solidFill>
                 <a:latin typeface="Malgun Gothic"/>
               </a:rPr>
-              <a:t>메타데이터 + 암호문</a:t>
+              <a:t>헤더 + 인증 암호문</a:t>
             </a:r>
           </a:p>
         </p:txBody>
@@ -20134,7 +20134,7 @@
                 </a:solidFill>
                 <a:latin typeface="Malgun Gothic"/>
               </a:rPr>
-              <a:t>무결성 검증</a:t>
+              <a:t>인증 검증</a:t>
             </a:r>
           </a:p>
         </p:txBody>
@@ -25192,7 +25192,7 @@
                 </a:solidFill>
                 <a:latin typeface="Consolas"/>
               </a:rPr>
-              <a:t>03 / BOOLEAN ALGEBRA</a:t>
+              <a:t>03 / CRYPTOGRAPHY</a:t>
             </a:r>
           </a:p>
         </p:txBody>
@@ -25227,7 +25227,7 @@
                 </a:solidFill>
                 <a:latin typeface="Malgun Gothic"/>
               </a:rPr>
-              <a:t>XOR: 같은 키를 두 번 적용하면 원래로 돌아온다</a:t>
+              <a:t>기본은 AES-GCM, XOR은 원리 학습용</a:t>
             </a:r>
           </a:p>
         </p:txBody>
@@ -25262,7 +25262,7 @@
                 </a:solidFill>
                 <a:latin typeface="Malgun Gothic"/>
               </a:rPr>
-              <a:t>XOR의 자기역원 성질을 이용해 암호화와 복호화를 같은 연산으로 처리합니다.</a:t>
+              <a:t>실제 패키지는 PBKDF2-SHA-256으로 키를 유도한 뒤 AES-256-GCM으로 인증 암호화합니다.</a:t>
             </a:r>
           </a:p>
         </p:txBody>
@@ -25426,7 +25426,7 @@
                 </a:solidFill>
                 <a:latin typeface="Malgun Gothic"/>
               </a:rPr>
-              <a:t>압축 데이터</a:t>
+              <a:t>비밀번호 + 새 salt</a:t>
             </a:r>
           </a:p>
         </p:txBody>
@@ -25461,7 +25461,7 @@
                 </a:solidFill>
                 <a:latin typeface="Consolas"/>
               </a:rPr>
-              <a:t>01001010 01100011</a:t>
+              <a:t>PBKDF2-SHA-256  (250,000회)</a:t>
             </a:r>
           </a:p>
         </p:txBody>
@@ -25578,7 +25578,7 @@
                 </a:solidFill>
                 <a:latin typeface="Malgun Gothic"/>
               </a:rPr>
-              <a:t>SHA-256 키 재료</a:t>
+              <a:t>새 IV + 압축 데이터</a:t>
             </a:r>
           </a:p>
         </p:txBody>
@@ -25613,7 +25613,7 @@
                 </a:solidFill>
                 <a:latin typeface="Consolas"/>
               </a:rPr>
-              <a:t>10110100 11001001</a:t>
+              <a:t>AES-256-GCM + 헤더 인증</a:t>
             </a:r>
           </a:p>
         </p:txBody>
@@ -25730,7 +25730,7 @@
                 </a:solidFill>
                 <a:latin typeface="Malgun Gothic"/>
               </a:rPr>
-              <a:t>암호문</a:t>
+              <a:t>SME2 암호문</a:t>
             </a:r>
           </a:p>
         </p:txBody>
@@ -25765,7 +25765,7 @@
                 </a:solidFill>
                 <a:latin typeface="Consolas"/>
               </a:rPr>
-              <a:t>11111110 10101010</a:t>
+              <a:t>변조 시 복호화 거부</a:t>
             </a:r>
           </a:p>
         </p:txBody>
@@ -25779,7 +25779,7 @@
         <p:spPr>
           <a:xfrm>
             <a:off x="822960" y="5513832"/>
-            <a:ext cx="1005840" cy="182880"/>
+            <a:ext cx="1234440" cy="182880"/>
           </a:xfrm>
           <a:prstGeom prst="rect">
             <a:avLst/>
@@ -25800,7 +25800,7 @@
                 </a:solidFill>
                 <a:latin typeface="Consolas"/>
               </a:rPr>
-              <a:t>키 처리</a:t>
+              <a:t>XOR 학습 모드</a:t>
             </a:r>
           </a:p>
         </p:txBody>
@@ -25813,8 +25813,8 @@
         </p:nvSpPr>
         <p:spPr>
           <a:xfrm>
-            <a:off x="1965960" y="5486400"/>
-            <a:ext cx="8961120" cy="256032"/>
+            <a:off x="2194560" y="5486400"/>
+            <a:ext cx="8686800" cy="256032"/>
           </a:xfrm>
           <a:prstGeom prst="rect">
             <a:avLst/>
@@ -25829,13 +25829,13 @@
           <a:p>
             <a:pPr algn="l"/>
             <a:r>
-              <a:rPr sz="1300" b="0">
+              <a:rPr sz="1200" b="0">
                 <a:solidFill>
                   <a:srgbClr val="A6C3C7"/>
                 </a:solidFill>
                 <a:latin typeface="Malgun Gothic"/>
               </a:rPr>
-              <a:t>사용자가 입력한 키를 SHA-256으로 32바이트까지 확장한 뒤 반복 적용</a:t>
+              <a:t>A ⊕ K ⊕ K = A 성질을 관찰하기 위한 호환용 SME1 모드이며, 새 파일의 기본값은 아닙니다.</a:t>
             </a:r>
           </a:p>
         </p:txBody>
@@ -27516,7 +27516,7 @@
                 </a:solidFill>
                 <a:latin typeface="Malgun Gothic"/>
               </a:rPr>
-              <a:t>Secure Message .enc 패키지와 무결성 검증</a:t>
+              <a:t>SME2 .enc 패키지와 인증 검증</a:t>
             </a:r>
           </a:p>
         </p:txBody>
@@ -27551,7 +27551,7 @@
                 </a:solidFill>
                 <a:latin typeface="Malgun Gothic"/>
               </a:rPr>
-              <a:t>암호문만으로도 복호화에 필요한 압축 정보와 손상 검증 정보를 함께 전달합니다.</a:t>
+              <a:t>복호화에 필요한 압축 정보, 키 유도 정보, 인증 암호문을 하나의 패키지로 전달합니다.</a:t>
             </a:r>
           </a:p>
         </p:txBody>
@@ -27633,7 +27633,7 @@
                 </a:solidFill>
                 <a:latin typeface="Consolas"/>
               </a:rPr>
-              <a:t>SME1</a:t>
+              <a:t>SME2</a:t>
             </a:r>
           </a:p>
         </p:txBody>
@@ -27984,7 +27984,7 @@
                 </a:solidFill>
                 <a:latin typeface="Consolas"/>
               </a:rPr>
-              <a:t>SHA-256</a:t>
+              <a:t>salt · IV</a:t>
             </a:r>
           </a:p>
         </p:txBody>
@@ -28019,7 +28019,7 @@
                 </a:solidFill>
                 <a:latin typeface="Malgun Gothic"/>
               </a:rPr>
-              <a:t>원본 무결성 해시</a:t>
+              <a:t>PBKDF2/AES-GCM 값</a:t>
             </a:r>
           </a:p>
         </p:txBody>
@@ -28101,7 +28101,7 @@
                 </a:solidFill>
                 <a:latin typeface="Consolas"/>
               </a:rPr>
-              <a:t>암호문</a:t>
+              <a:t>암호문 + 태그</a:t>
             </a:r>
           </a:p>
         </p:txBody>
@@ -28136,7 +28136,7 @@
                 </a:solidFill>
                 <a:latin typeface="Malgun Gothic"/>
               </a:rPr>
-              <a:t>XOR 처리된 압축 데이터</a:t>
+              <a:t>변조 검출</a:t>
             </a:r>
           </a:p>
         </p:txBody>
@@ -28286,7 +28286,7 @@
                 </a:solidFill>
                 <a:latin typeface="Malgun Gothic"/>
               </a:rPr>
-              <a:t>XOR 복호화</a:t>
+              <a:t>AES-GCM 인증 복호화</a:t>
             </a:r>
           </a:p>
         </p:txBody>
@@ -28586,7 +28586,7 @@
                 </a:solidFill>
                 <a:latin typeface="Malgun Gothic"/>
               </a:rPr>
-              <a:t>원본 SHA-256 계산</a:t>
+              <a:t>원본 바이트 복원</a:t>
             </a:r>
           </a:p>
         </p:txBody>
@@ -28736,7 +28736,7 @@
                 </a:solidFill>
                 <a:latin typeface="Malgun Gothic"/>
               </a:rPr>
-              <a:t>패키지 해시와 비교</a:t>
+              <a:t>변조·오류 시 즉시 거부</a:t>
             </a:r>
           </a:p>
         </p:txBody>
@@ -34286,7 +34286,7 @@
                 </a:solidFill>
                 <a:latin typeface="Malgun Gothic"/>
               </a:rPr>
-              <a:t>텍스트/파일 입력, 25MB 제한, .enc 다운로드</a:t>
+              <a:t>PBKDF2 + AES-GCM 기본, 25MB 제한, .enc 다운로드</a:t>
             </a:r>
           </a:p>
         </p:txBody>
@@ -34483,7 +34483,7 @@
                 </a:solidFill>
                 <a:latin typeface="Malgun Gothic"/>
               </a:rPr>
-              <a:t>동일 키 입력, 해시 검증 후 원본 복원</a:t>
+              <a:t>동일 키 입력, 인증 검증 후 원본 복원</a:t>
             </a:r>
           </a:p>
         </p:txBody>
@@ -34877,7 +34877,7 @@
                 </a:solidFill>
                 <a:latin typeface="Malgun Gothic"/>
               </a:rPr>
-              <a:t>원본과 암호문의 바이트 빈도 분포 비교</a:t>
+              <a:t>XOR 학습용 바이트 빈도 분포 비교</a:t>
             </a:r>
           </a:p>
         </p:txBody>

</xml_diff>